<commit_message>
feat(古墓): 27 張補圖全部接上，bgPending 清空 ver -1647
美術 0aed7cb 交件 28 張（27 格 ＋ 底層祭壇的前後差分）。

程式端只做一件：那 27 格的 `bg` 改成正式檔名、拔掉 `bgPending`。
· 底層祭壇的 `bgWhen:[{ not:'tomb_altar_on', bg:'tomb_lowaltar_off' }]` 照舊
  —— 兩張都在，啟動前後差分現在真的有東西可切
· 全部新檔名（不是同名覆蓋）⇒ `ASSET_VER` 不必動

驗過：27/27 檔案到位、尺寸全部 1536×1024（古墓現有 72 張同規格）、
`script_lint.py` 的「暫時借用」提醒從 28 條降到 1 條（只剩雪都大教堂）。
PPT 重出，綠方塊全部換回縮圖。

⚠ 小地圖那兩件（羊皮紙 ＋ 61 格圖示表）還沒交，照舊是 34 格版。

Co-Authored-By: Claude Opus 5 <noreply@anthropic.com>
</commit_message>
<xml_diff>
--- a/resources/map/_layout_tomb.pptx
+++ b/resources/map/_layout_tomb.pptx
@@ -4021,12 +4021,20 @@
             <a:chExt cx="1280000" cy="1020000"/>
           </a:xfrm>
         </p:grpSpPr>
-        <p:sp>
-          <p:nvSpPr>
-            <p:cNvPr id="37" name="Rectangle 36"/>
-            <p:cNvSpPr/>
-            <p:nvPr/>
-          </p:nvSpPr>
+        <p:pic>
+          <p:nvPicPr>
+            <p:cNvPr id="37" name="Picture 36" descr="tomb_scriptorium.webp.jpg"/>
+            <p:cNvPicPr>
+              <a:picLocks noChangeAspect="1"/>
+            </p:cNvPicPr>
+            <p:nvPr/>
+          </p:nvPicPr>
+          <p:blipFill>
+            <a:blip r:embed="rId13"/>
+            <a:stretch>
+              <a:fillRect/>
+            </a:stretch>
+          </p:blipFill>
           <p:spPr>
             <a:xfrm>
               <a:off x="6300000" y="14800000"/>
@@ -4035,54 +4043,8 @@
             <a:prstGeom prst="rect">
               <a:avLst/>
             </a:prstGeom>
-            <a:solidFill>
-              <a:srgbClr val="3FB950"/>
-            </a:solidFill>
-            <a:ln>
-              <a:solidFill>
-                <a:srgbClr val="2B8A3A"/>
-              </a:solidFill>
-            </a:ln>
-          </p:spPr>
-          <p:style>
-            <a:lnRef idx="1">
-              <a:schemeClr val="accent1"/>
-            </a:lnRef>
-            <a:fillRef idx="3">
-              <a:schemeClr val="accent1"/>
-            </a:fillRef>
-            <a:effectRef idx="2">
-              <a:schemeClr val="accent1"/>
-            </a:effectRef>
-            <a:fontRef idx="minor">
-              <a:schemeClr val="lt1"/>
-            </a:fontRef>
-          </p:style>
-          <p:txBody>
-            <a:bodyPr rtlCol="0" anchor="ctr"/>
-            <a:lstStyle/>
-            <a:p>
-              <a:r>
-                <a:rPr sz="900" b="1">
-                  <a:solidFill>
-                    <a:srgbClr val="FFFFFF"/>
-                  </a:solidFill>
-                </a:rPr>
-                <a:t>要補圖</a:t>
-              </a:r>
-            </a:p>
-            <a:p>
-              <a:r>
-                <a:rPr sz="900" b="1">
-                  <a:solidFill>
-                    <a:srgbClr val="FFFFFF"/>
-                  </a:solidFill>
-                </a:rPr>
-                <a:t>tomb_scriptorium</a:t>
-              </a:r>
-            </a:p>
-          </p:txBody>
-        </p:sp>
+          </p:spPr>
+        </p:pic>
         <p:sp>
           <p:nvSpPr>
             <p:cNvPr id="38" name="TextBox 37"/>
@@ -4148,7 +4110,7 @@
             <p:nvPr/>
           </p:nvPicPr>
           <p:blipFill>
-            <a:blip r:embed="rId13"/>
+            <a:blip r:embed="rId14"/>
             <a:stretch>
               <a:fillRect/>
             </a:stretch>
@@ -4219,12 +4181,20 @@
             <a:chExt cx="1280000" cy="1020000"/>
           </a:xfrm>
         </p:grpSpPr>
-        <p:sp>
-          <p:nvSpPr>
-            <p:cNvPr id="43" name="Rectangle 42"/>
-            <p:cNvSpPr/>
-            <p:nvPr/>
-          </p:nvSpPr>
+        <p:pic>
+          <p:nvPicPr>
+            <p:cNvPr id="43" name="Picture 42" descr="tomb_confessio.webp.jpg"/>
+            <p:cNvPicPr>
+              <a:picLocks noChangeAspect="1"/>
+            </p:cNvPicPr>
+            <p:nvPr/>
+          </p:nvPicPr>
+          <p:blipFill>
+            <a:blip r:embed="rId15"/>
+            <a:stretch>
+              <a:fillRect/>
+            </a:stretch>
+          </p:blipFill>
           <p:spPr>
             <a:xfrm>
               <a:off x="18300000" y="14800000"/>
@@ -4233,54 +4203,8 @@
             <a:prstGeom prst="rect">
               <a:avLst/>
             </a:prstGeom>
-            <a:solidFill>
-              <a:srgbClr val="3FB950"/>
-            </a:solidFill>
-            <a:ln>
-              <a:solidFill>
-                <a:srgbClr val="2B8A3A"/>
-              </a:solidFill>
-            </a:ln>
-          </p:spPr>
-          <p:style>
-            <a:lnRef idx="1">
-              <a:schemeClr val="accent1"/>
-            </a:lnRef>
-            <a:fillRef idx="3">
-              <a:schemeClr val="accent1"/>
-            </a:fillRef>
-            <a:effectRef idx="2">
-              <a:schemeClr val="accent1"/>
-            </a:effectRef>
-            <a:fontRef idx="minor">
-              <a:schemeClr val="lt1"/>
-            </a:fontRef>
-          </p:style>
-          <p:txBody>
-            <a:bodyPr rtlCol="0" anchor="ctr"/>
-            <a:lstStyle/>
-            <a:p>
-              <a:r>
-                <a:rPr sz="900" b="1">
-                  <a:solidFill>
-                    <a:srgbClr val="FFFFFF"/>
-                  </a:solidFill>
-                </a:rPr>
-                <a:t>要補圖</a:t>
-              </a:r>
-            </a:p>
-            <a:p>
-              <a:r>
-                <a:rPr sz="900" b="1">
-                  <a:solidFill>
-                    <a:srgbClr val="FFFFFF"/>
-                  </a:solidFill>
-                </a:rPr>
-                <a:t>tomb_confessio</a:t>
-              </a:r>
-            </a:p>
-          </p:txBody>
-        </p:sp>
+          </p:spPr>
+        </p:pic>
         <p:sp>
           <p:nvSpPr>
             <p:cNvPr id="44" name="TextBox 43"/>
@@ -4346,7 +4270,7 @@
             <p:nvPr/>
           </p:nvPicPr>
           <p:blipFill>
-            <a:blip r:embed="rId14"/>
+            <a:blip r:embed="rId16"/>
             <a:stretch>
               <a:fillRect/>
             </a:stretch>
@@ -4417,12 +4341,20 @@
             <a:chExt cx="1280000" cy="1020000"/>
           </a:xfrm>
         </p:grpSpPr>
-        <p:sp>
-          <p:nvSpPr>
-            <p:cNvPr id="49" name="Rectangle 48"/>
-            <p:cNvSpPr/>
-            <p:nvPr/>
-          </p:nvSpPr>
+        <p:pic>
+          <p:nvPicPr>
+            <p:cNvPr id="49" name="Picture 48" descr="tomb_sacristy.webp.jpg"/>
+            <p:cNvPicPr>
+              <a:picLocks noChangeAspect="1"/>
+            </p:cNvPicPr>
+            <p:nvPr/>
+          </p:nvPicPr>
+          <p:blipFill>
+            <a:blip r:embed="rId17"/>
+            <a:stretch>
+              <a:fillRect/>
+            </a:stretch>
+          </p:blipFill>
           <p:spPr>
             <a:xfrm>
               <a:off x="15300000" y="12500000"/>
@@ -4431,54 +4363,8 @@
             <a:prstGeom prst="rect">
               <a:avLst/>
             </a:prstGeom>
-            <a:solidFill>
-              <a:srgbClr val="3FB950"/>
-            </a:solidFill>
-            <a:ln>
-              <a:solidFill>
-                <a:srgbClr val="2B8A3A"/>
-              </a:solidFill>
-            </a:ln>
-          </p:spPr>
-          <p:style>
-            <a:lnRef idx="1">
-              <a:schemeClr val="accent1"/>
-            </a:lnRef>
-            <a:fillRef idx="3">
-              <a:schemeClr val="accent1"/>
-            </a:fillRef>
-            <a:effectRef idx="2">
-              <a:schemeClr val="accent1"/>
-            </a:effectRef>
-            <a:fontRef idx="minor">
-              <a:schemeClr val="lt1"/>
-            </a:fontRef>
-          </p:style>
-          <p:txBody>
-            <a:bodyPr rtlCol="0" anchor="ctr"/>
-            <a:lstStyle/>
-            <a:p>
-              <a:r>
-                <a:rPr sz="900" b="1">
-                  <a:solidFill>
-                    <a:srgbClr val="FFFFFF"/>
-                  </a:solidFill>
-                </a:rPr>
-                <a:t>要補圖</a:t>
-              </a:r>
-            </a:p>
-            <a:p>
-              <a:r>
-                <a:rPr sz="900" b="1">
-                  <a:solidFill>
-                    <a:srgbClr val="FFFFFF"/>
-                  </a:solidFill>
-                </a:rPr>
-                <a:t>tomb_sacristy</a:t>
-              </a:r>
-            </a:p>
-          </p:txBody>
-        </p:sp>
+          </p:spPr>
+        </p:pic>
         <p:sp>
           <p:nvSpPr>
             <p:cNvPr id="50" name="TextBox 49"/>
@@ -4544,7 +4430,7 @@
             <p:nvPr/>
           </p:nvPicPr>
           <p:blipFill>
-            <a:blip r:embed="rId15"/>
+            <a:blip r:embed="rId18"/>
             <a:stretch>
               <a:fillRect/>
             </a:stretch>
@@ -4624,7 +4510,7 @@
             <p:nvPr/>
           </p:nvPicPr>
           <p:blipFill>
-            <a:blip r:embed="rId16"/>
+            <a:blip r:embed="rId19"/>
             <a:stretch>
               <a:fillRect/>
             </a:stretch>
@@ -4704,7 +4590,7 @@
             <p:nvPr/>
           </p:nvPicPr>
           <p:blipFill>
-            <a:blip r:embed="rId17"/>
+            <a:blip r:embed="rId20"/>
             <a:stretch>
               <a:fillRect/>
             </a:stretch>
@@ -4775,12 +4661,20 @@
             <a:chExt cx="1280000" cy="1020000"/>
           </a:xfrm>
         </p:grpSpPr>
-        <p:sp>
-          <p:nvSpPr>
-            <p:cNvPr id="61" name="Rectangle 60"/>
-            <p:cNvSpPr/>
-            <p:nvPr/>
-          </p:nvSpPr>
+        <p:pic>
+          <p:nvPicPr>
+            <p:cNvPr id="61" name="Picture 60" descr="tomb_wellyard.webp.jpg"/>
+            <p:cNvPicPr>
+              <a:picLocks noChangeAspect="1"/>
+            </p:cNvPicPr>
+            <p:nvPr/>
+          </p:nvPicPr>
+          <p:blipFill>
+            <a:blip r:embed="rId21"/>
+            <a:stretch>
+              <a:fillRect/>
+            </a:stretch>
+          </p:blipFill>
           <p:spPr>
             <a:xfrm>
               <a:off x="9300000" y="12500000"/>
@@ -4789,54 +4683,8 @@
             <a:prstGeom prst="rect">
               <a:avLst/>
             </a:prstGeom>
-            <a:solidFill>
-              <a:srgbClr val="3FB950"/>
-            </a:solidFill>
-            <a:ln>
-              <a:solidFill>
-                <a:srgbClr val="2B8A3A"/>
-              </a:solidFill>
-            </a:ln>
-          </p:spPr>
-          <p:style>
-            <a:lnRef idx="1">
-              <a:schemeClr val="accent1"/>
-            </a:lnRef>
-            <a:fillRef idx="3">
-              <a:schemeClr val="accent1"/>
-            </a:fillRef>
-            <a:effectRef idx="2">
-              <a:schemeClr val="accent1"/>
-            </a:effectRef>
-            <a:fontRef idx="minor">
-              <a:schemeClr val="lt1"/>
-            </a:fontRef>
-          </p:style>
-          <p:txBody>
-            <a:bodyPr rtlCol="0" anchor="ctr"/>
-            <a:lstStyle/>
-            <a:p>
-              <a:r>
-                <a:rPr sz="900" b="1">
-                  <a:solidFill>
-                    <a:srgbClr val="FFFFFF"/>
-                  </a:solidFill>
-                </a:rPr>
-                <a:t>要補圖</a:t>
-              </a:r>
-            </a:p>
-            <a:p>
-              <a:r>
-                <a:rPr sz="900" b="1">
-                  <a:solidFill>
-                    <a:srgbClr val="FFFFFF"/>
-                  </a:solidFill>
-                </a:rPr>
-                <a:t>tomb_wellyard</a:t>
-              </a:r>
-            </a:p>
-          </p:txBody>
-        </p:sp>
+          </p:spPr>
+        </p:pic>
         <p:sp>
           <p:nvSpPr>
             <p:cNvPr id="62" name="TextBox 61"/>
@@ -4902,7 +4750,7 @@
             <p:nvPr/>
           </p:nvPicPr>
           <p:blipFill>
-            <a:blip r:embed="rId18"/>
+            <a:blip r:embed="rId22"/>
             <a:stretch>
               <a:fillRect/>
             </a:stretch>
@@ -4982,7 +4830,7 @@
             <p:nvPr/>
           </p:nvPicPr>
           <p:blipFill>
-            <a:blip r:embed="rId19"/>
+            <a:blip r:embed="rId23"/>
             <a:stretch>
               <a:fillRect/>
             </a:stretch>
@@ -5062,7 +4910,7 @@
             <p:nvPr/>
           </p:nvPicPr>
           <p:blipFill>
-            <a:blip r:embed="rId20"/>
+            <a:blip r:embed="rId24"/>
             <a:stretch>
               <a:fillRect/>
             </a:stretch>
@@ -5133,12 +4981,20 @@
             <a:chExt cx="1280000" cy="1020000"/>
           </a:xfrm>
         </p:grpSpPr>
-        <p:sp>
-          <p:nvSpPr>
-            <p:cNvPr id="73" name="Rectangle 72"/>
-            <p:cNvSpPr/>
-            <p:nvPr/>
-          </p:nvSpPr>
+        <p:pic>
+          <p:nvPicPr>
+            <p:cNvPr id="73" name="Picture 72" descr="tomb_colonnade.webp.jpg"/>
+            <p:cNvPicPr>
+              <a:picLocks noChangeAspect="1"/>
+            </p:cNvPicPr>
+            <p:nvPr/>
+          </p:nvPicPr>
+          <p:blipFill>
+            <a:blip r:embed="rId25"/>
+            <a:stretch>
+              <a:fillRect/>
+            </a:stretch>
+          </p:blipFill>
           <p:spPr>
             <a:xfrm>
               <a:off x="3300000" y="9050000"/>
@@ -5147,54 +5003,8 @@
             <a:prstGeom prst="rect">
               <a:avLst/>
             </a:prstGeom>
-            <a:solidFill>
-              <a:srgbClr val="3FB950"/>
-            </a:solidFill>
-            <a:ln>
-              <a:solidFill>
-                <a:srgbClr val="2B8A3A"/>
-              </a:solidFill>
-            </a:ln>
-          </p:spPr>
-          <p:style>
-            <a:lnRef idx="1">
-              <a:schemeClr val="accent1"/>
-            </a:lnRef>
-            <a:fillRef idx="3">
-              <a:schemeClr val="accent1"/>
-            </a:fillRef>
-            <a:effectRef idx="2">
-              <a:schemeClr val="accent1"/>
-            </a:effectRef>
-            <a:fontRef idx="minor">
-              <a:schemeClr val="lt1"/>
-            </a:fontRef>
-          </p:style>
-          <p:txBody>
-            <a:bodyPr rtlCol="0" anchor="ctr"/>
-            <a:lstStyle/>
-            <a:p>
-              <a:r>
-                <a:rPr sz="900" b="1">
-                  <a:solidFill>
-                    <a:srgbClr val="FFFFFF"/>
-                  </a:solidFill>
-                </a:rPr>
-                <a:t>要補圖</a:t>
-              </a:r>
-            </a:p>
-            <a:p>
-              <a:r>
-                <a:rPr sz="900" b="1">
-                  <a:solidFill>
-                    <a:srgbClr val="FFFFFF"/>
-                  </a:solidFill>
-                </a:rPr>
-                <a:t>tomb_colonnade</a:t>
-              </a:r>
-            </a:p>
-          </p:txBody>
-        </p:sp>
+          </p:spPr>
+        </p:pic>
         <p:sp>
           <p:nvSpPr>
             <p:cNvPr id="74" name="TextBox 73"/>
@@ -5251,12 +5061,20 @@
             <a:chExt cx="1280000" cy="1020000"/>
           </a:xfrm>
         </p:grpSpPr>
-        <p:sp>
-          <p:nvSpPr>
-            <p:cNvPr id="76" name="Rectangle 75"/>
-            <p:cNvSpPr/>
-            <p:nvPr/>
-          </p:nvSpPr>
+        <p:pic>
+          <p:nvPicPr>
+            <p:cNvPr id="76" name="Picture 75" descr="tomb_mason.webp.jpg"/>
+            <p:cNvPicPr>
+              <a:picLocks noChangeAspect="1"/>
+            </p:cNvPicPr>
+            <p:nvPr/>
+          </p:nvPicPr>
+          <p:blipFill>
+            <a:blip r:embed="rId26"/>
+            <a:stretch>
+              <a:fillRect/>
+            </a:stretch>
+          </p:blipFill>
           <p:spPr>
             <a:xfrm>
               <a:off x="3300000" y="7900000"/>
@@ -5265,54 +5083,8 @@
             <a:prstGeom prst="rect">
               <a:avLst/>
             </a:prstGeom>
-            <a:solidFill>
-              <a:srgbClr val="3FB950"/>
-            </a:solidFill>
-            <a:ln>
-              <a:solidFill>
-                <a:srgbClr val="2B8A3A"/>
-              </a:solidFill>
-            </a:ln>
-          </p:spPr>
-          <p:style>
-            <a:lnRef idx="1">
-              <a:schemeClr val="accent1"/>
-            </a:lnRef>
-            <a:fillRef idx="3">
-              <a:schemeClr val="accent1"/>
-            </a:fillRef>
-            <a:effectRef idx="2">
-              <a:schemeClr val="accent1"/>
-            </a:effectRef>
-            <a:fontRef idx="minor">
-              <a:schemeClr val="lt1"/>
-            </a:fontRef>
-          </p:style>
-          <p:txBody>
-            <a:bodyPr rtlCol="0" anchor="ctr"/>
-            <a:lstStyle/>
-            <a:p>
-              <a:r>
-                <a:rPr sz="900" b="1">
-                  <a:solidFill>
-                    <a:srgbClr val="FFFFFF"/>
-                  </a:solidFill>
-                </a:rPr>
-                <a:t>要補圖</a:t>
-              </a:r>
-            </a:p>
-            <a:p>
-              <a:r>
-                <a:rPr sz="900" b="1">
-                  <a:solidFill>
-                    <a:srgbClr val="FFFFFF"/>
-                  </a:solidFill>
-                </a:rPr>
-                <a:t>tomb_mason</a:t>
-              </a:r>
-            </a:p>
-          </p:txBody>
-        </p:sp>
+          </p:spPr>
+        </p:pic>
         <p:sp>
           <p:nvSpPr>
             <p:cNvPr id="77" name="TextBox 76"/>
@@ -5378,7 +5150,7 @@
             <p:nvPr/>
           </p:nvPicPr>
           <p:blipFill>
-            <a:blip r:embed="rId21"/>
+            <a:blip r:embed="rId27"/>
             <a:stretch>
               <a:fillRect/>
             </a:stretch>
@@ -5449,12 +5221,20 @@
             <a:chExt cx="1280000" cy="1020000"/>
           </a:xfrm>
         </p:grpSpPr>
-        <p:sp>
-          <p:nvSpPr>
-            <p:cNvPr id="82" name="Rectangle 81"/>
-            <p:cNvSpPr/>
-            <p:nvPr/>
-          </p:nvSpPr>
+        <p:pic>
+          <p:nvPicPr>
+            <p:cNvPr id="82" name="Picture 81" descr="tomb_waterstair.webp.jpg"/>
+            <p:cNvPicPr>
+              <a:picLocks noChangeAspect="1"/>
+            </p:cNvPicPr>
+            <p:nvPr/>
+          </p:nvPicPr>
+          <p:blipFill>
+            <a:blip r:embed="rId28"/>
+            <a:stretch>
+              <a:fillRect/>
+            </a:stretch>
+          </p:blipFill>
           <p:spPr>
             <a:xfrm>
               <a:off x="6300000" y="6750000"/>
@@ -5463,54 +5243,8 @@
             <a:prstGeom prst="rect">
               <a:avLst/>
             </a:prstGeom>
-            <a:solidFill>
-              <a:srgbClr val="3FB950"/>
-            </a:solidFill>
-            <a:ln>
-              <a:solidFill>
-                <a:srgbClr val="2B8A3A"/>
-              </a:solidFill>
-            </a:ln>
-          </p:spPr>
-          <p:style>
-            <a:lnRef idx="1">
-              <a:schemeClr val="accent1"/>
-            </a:lnRef>
-            <a:fillRef idx="3">
-              <a:schemeClr val="accent1"/>
-            </a:fillRef>
-            <a:effectRef idx="2">
-              <a:schemeClr val="accent1"/>
-            </a:effectRef>
-            <a:fontRef idx="minor">
-              <a:schemeClr val="lt1"/>
-            </a:fontRef>
-          </p:style>
-          <p:txBody>
-            <a:bodyPr rtlCol="0" anchor="ctr"/>
-            <a:lstStyle/>
-            <a:p>
-              <a:r>
-                <a:rPr sz="900" b="1">
-                  <a:solidFill>
-                    <a:srgbClr val="FFFFFF"/>
-                  </a:solidFill>
-                </a:rPr>
-                <a:t>要補圖</a:t>
-              </a:r>
-            </a:p>
-            <a:p>
-              <a:r>
-                <a:rPr sz="900" b="1">
-                  <a:solidFill>
-                    <a:srgbClr val="FFFFFF"/>
-                  </a:solidFill>
-                </a:rPr>
-                <a:t>tomb_waterstair</a:t>
-              </a:r>
-            </a:p>
-          </p:txBody>
-        </p:sp>
+          </p:spPr>
+        </p:pic>
         <p:sp>
           <p:nvSpPr>
             <p:cNvPr id="83" name="TextBox 82"/>
@@ -5576,7 +5310,7 @@
             <p:nvPr/>
           </p:nvPicPr>
           <p:blipFill>
-            <a:blip r:embed="rId22"/>
+            <a:blip r:embed="rId29"/>
             <a:stretch>
               <a:fillRect/>
             </a:stretch>
@@ -5656,7 +5390,7 @@
             <p:nvPr/>
           </p:nvPicPr>
           <p:blipFill>
-            <a:blip r:embed="rId23"/>
+            <a:blip r:embed="rId30"/>
             <a:stretch>
               <a:fillRect/>
             </a:stretch>
@@ -5736,7 +5470,7 @@
             <p:nvPr/>
           </p:nvPicPr>
           <p:blipFill>
-            <a:blip r:embed="rId24"/>
+            <a:blip r:embed="rId31"/>
             <a:stretch>
               <a:fillRect/>
             </a:stretch>
@@ -5807,12 +5541,20 @@
             <a:chExt cx="1280000" cy="1020000"/>
           </a:xfrm>
         </p:grpSpPr>
-        <p:sp>
-          <p:nvSpPr>
-            <p:cNvPr id="94" name="Rectangle 93"/>
-            <p:cNvSpPr/>
-            <p:nvPr/>
-          </p:nvSpPr>
+        <p:pic>
+          <p:nvPicPr>
+            <p:cNvPr id="94" name="Picture 93" descr="tomb_censerroom.webp.jpg"/>
+            <p:cNvPicPr>
+              <a:picLocks noChangeAspect="1"/>
+            </p:cNvPicPr>
+            <p:nvPr/>
+          </p:nvPicPr>
+          <p:blipFill>
+            <a:blip r:embed="rId32"/>
+            <a:stretch>
+              <a:fillRect/>
+            </a:stretch>
+          </p:blipFill>
           <p:spPr>
             <a:xfrm>
               <a:off x="12300000" y="10200000"/>
@@ -5821,54 +5563,8 @@
             <a:prstGeom prst="rect">
               <a:avLst/>
             </a:prstGeom>
-            <a:solidFill>
-              <a:srgbClr val="3FB950"/>
-            </a:solidFill>
-            <a:ln>
-              <a:solidFill>
-                <a:srgbClr val="2B8A3A"/>
-              </a:solidFill>
-            </a:ln>
-          </p:spPr>
-          <p:style>
-            <a:lnRef idx="1">
-              <a:schemeClr val="accent1"/>
-            </a:lnRef>
-            <a:fillRef idx="3">
-              <a:schemeClr val="accent1"/>
-            </a:fillRef>
-            <a:effectRef idx="2">
-              <a:schemeClr val="accent1"/>
-            </a:effectRef>
-            <a:fontRef idx="minor">
-              <a:schemeClr val="lt1"/>
-            </a:fontRef>
-          </p:style>
-          <p:txBody>
-            <a:bodyPr rtlCol="0" anchor="ctr"/>
-            <a:lstStyle/>
-            <a:p>
-              <a:r>
-                <a:rPr sz="900" b="1">
-                  <a:solidFill>
-                    <a:srgbClr val="FFFFFF"/>
-                  </a:solidFill>
-                </a:rPr>
-                <a:t>要補圖</a:t>
-              </a:r>
-            </a:p>
-            <a:p>
-              <a:r>
-                <a:rPr sz="900" b="1">
-                  <a:solidFill>
-                    <a:srgbClr val="FFFFFF"/>
-                  </a:solidFill>
-                </a:rPr>
-                <a:t>tomb_censerroom</a:t>
-              </a:r>
-            </a:p>
-          </p:txBody>
-        </p:sp>
+          </p:spPr>
+        </p:pic>
         <p:sp>
           <p:nvSpPr>
             <p:cNvPr id="95" name="TextBox 94"/>
@@ -5934,7 +5630,7 @@
             <p:nvPr/>
           </p:nvPicPr>
           <p:blipFill>
-            <a:blip r:embed="rId25"/>
+            <a:blip r:embed="rId33"/>
             <a:stretch>
               <a:fillRect/>
             </a:stretch>
@@ -6014,7 +5710,7 @@
             <p:nvPr/>
           </p:nvPicPr>
           <p:blipFill>
-            <a:blip r:embed="rId26"/>
+            <a:blip r:embed="rId34"/>
             <a:stretch>
               <a:fillRect/>
             </a:stretch>
@@ -6094,7 +5790,7 @@
             <p:nvPr/>
           </p:nvPicPr>
           <p:blipFill>
-            <a:blip r:embed="rId27"/>
+            <a:blip r:embed="rId35"/>
             <a:stretch>
               <a:fillRect/>
             </a:stretch>
@@ -6174,7 +5870,7 @@
             <p:nvPr/>
           </p:nvPicPr>
           <p:blipFill>
-            <a:blip r:embed="rId28"/>
+            <a:blip r:embed="rId36"/>
             <a:stretch>
               <a:fillRect/>
             </a:stretch>
@@ -6254,7 +5950,7 @@
             <p:nvPr/>
           </p:nvPicPr>
           <p:blipFill>
-            <a:blip r:embed="rId29"/>
+            <a:blip r:embed="rId37"/>
             <a:stretch>
               <a:fillRect/>
             </a:stretch>
@@ -6325,12 +6021,20 @@
             <a:chExt cx="1280000" cy="1020000"/>
           </a:xfrm>
         </p:grpSpPr>
-        <p:sp>
-          <p:nvSpPr>
-            <p:cNvPr id="112" name="Rectangle 111"/>
-            <p:cNvSpPr/>
-            <p:nvPr/>
-          </p:nvSpPr>
+        <p:pic>
+          <p:nvPicPr>
+            <p:cNvPr id="112" name="Picture 111" descr="tomb_shaft.webp.jpg"/>
+            <p:cNvPicPr>
+              <a:picLocks noChangeAspect="1"/>
+            </p:cNvPicPr>
+            <p:nvPr/>
+          </p:nvPicPr>
+          <p:blipFill>
+            <a:blip r:embed="rId38"/>
+            <a:stretch>
+              <a:fillRect/>
+            </a:stretch>
+          </p:blipFill>
           <p:spPr>
             <a:xfrm>
               <a:off x="15300000" y="10200000"/>
@@ -6339,54 +6043,8 @@
             <a:prstGeom prst="rect">
               <a:avLst/>
             </a:prstGeom>
-            <a:solidFill>
-              <a:srgbClr val="3FB950"/>
-            </a:solidFill>
-            <a:ln>
-              <a:solidFill>
-                <a:srgbClr val="2B8A3A"/>
-              </a:solidFill>
-            </a:ln>
-          </p:spPr>
-          <p:style>
-            <a:lnRef idx="1">
-              <a:schemeClr val="accent1"/>
-            </a:lnRef>
-            <a:fillRef idx="3">
-              <a:schemeClr val="accent1"/>
-            </a:fillRef>
-            <a:effectRef idx="2">
-              <a:schemeClr val="accent1"/>
-            </a:effectRef>
-            <a:fontRef idx="minor">
-              <a:schemeClr val="lt1"/>
-            </a:fontRef>
-          </p:style>
-          <p:txBody>
-            <a:bodyPr rtlCol="0" anchor="ctr"/>
-            <a:lstStyle/>
-            <a:p>
-              <a:r>
-                <a:rPr sz="900" b="1">
-                  <a:solidFill>
-                    <a:srgbClr val="FFFFFF"/>
-                  </a:solidFill>
-                </a:rPr>
-                <a:t>要補圖</a:t>
-              </a:r>
-            </a:p>
-            <a:p>
-              <a:r>
-                <a:rPr sz="900" b="1">
-                  <a:solidFill>
-                    <a:srgbClr val="FFFFFF"/>
-                  </a:solidFill>
-                </a:rPr>
-                <a:t>tomb_shaft</a:t>
-              </a:r>
-            </a:p>
-          </p:txBody>
-        </p:sp>
+          </p:spPr>
+        </p:pic>
         <p:sp>
           <p:nvSpPr>
             <p:cNvPr id="113" name="TextBox 112"/>
@@ -6443,12 +6101,20 @@
             <a:chExt cx="1280000" cy="1020000"/>
           </a:xfrm>
         </p:grpSpPr>
-        <p:sp>
-          <p:nvSpPr>
-            <p:cNvPr id="115" name="Rectangle 114"/>
-            <p:cNvSpPr/>
-            <p:nvPr/>
-          </p:nvSpPr>
+        <p:pic>
+          <p:nvPicPr>
+            <p:cNvPr id="115" name="Picture 114" descr="tomb_urnvault.webp.jpg"/>
+            <p:cNvPicPr>
+              <a:picLocks noChangeAspect="1"/>
+            </p:cNvPicPr>
+            <p:nvPr/>
+          </p:nvPicPr>
+          <p:blipFill>
+            <a:blip r:embed="rId39"/>
+            <a:stretch>
+              <a:fillRect/>
+            </a:stretch>
+          </p:blipFill>
           <p:spPr>
             <a:xfrm>
               <a:off x="21300000" y="9050000"/>
@@ -6457,54 +6123,8 @@
             <a:prstGeom prst="rect">
               <a:avLst/>
             </a:prstGeom>
-            <a:solidFill>
-              <a:srgbClr val="3FB950"/>
-            </a:solidFill>
-            <a:ln>
-              <a:solidFill>
-                <a:srgbClr val="2B8A3A"/>
-              </a:solidFill>
-            </a:ln>
-          </p:spPr>
-          <p:style>
-            <a:lnRef idx="1">
-              <a:schemeClr val="accent1"/>
-            </a:lnRef>
-            <a:fillRef idx="3">
-              <a:schemeClr val="accent1"/>
-            </a:fillRef>
-            <a:effectRef idx="2">
-              <a:schemeClr val="accent1"/>
-            </a:effectRef>
-            <a:fontRef idx="minor">
-              <a:schemeClr val="lt1"/>
-            </a:fontRef>
-          </p:style>
-          <p:txBody>
-            <a:bodyPr rtlCol="0" anchor="ctr"/>
-            <a:lstStyle/>
-            <a:p>
-              <a:r>
-                <a:rPr sz="900" b="1">
-                  <a:solidFill>
-                    <a:srgbClr val="FFFFFF"/>
-                  </a:solidFill>
-                </a:rPr>
-                <a:t>要補圖</a:t>
-              </a:r>
-            </a:p>
-            <a:p>
-              <a:r>
-                <a:rPr sz="900" b="1">
-                  <a:solidFill>
-                    <a:srgbClr val="FFFFFF"/>
-                  </a:solidFill>
-                </a:rPr>
-                <a:t>tomb_urnvault</a:t>
-              </a:r>
-            </a:p>
-          </p:txBody>
-        </p:sp>
+          </p:spPr>
+        </p:pic>
         <p:sp>
           <p:nvSpPr>
             <p:cNvPr id="116" name="TextBox 115"/>
@@ -6561,12 +6181,20 @@
             <a:chExt cx="1280000" cy="1020000"/>
           </a:xfrm>
         </p:grpSpPr>
-        <p:sp>
-          <p:nvSpPr>
-            <p:cNvPr id="118" name="Rectangle 117"/>
-            <p:cNvSpPr/>
-            <p:nvPr/>
-          </p:nvSpPr>
+        <p:pic>
+          <p:nvPicPr>
+            <p:cNvPr id="118" name="Picture 117" descr="tomb_ashpit.webp.jpg"/>
+            <p:cNvPicPr>
+              <a:picLocks noChangeAspect="1"/>
+            </p:cNvPicPr>
+            <p:nvPr/>
+          </p:nvPicPr>
+          <p:blipFill>
+            <a:blip r:embed="rId40"/>
+            <a:stretch>
+              <a:fillRect/>
+            </a:stretch>
+          </p:blipFill>
           <p:spPr>
             <a:xfrm>
               <a:off x="21300000" y="10200000"/>
@@ -6575,54 +6203,8 @@
             <a:prstGeom prst="rect">
               <a:avLst/>
             </a:prstGeom>
-            <a:solidFill>
-              <a:srgbClr val="3FB950"/>
-            </a:solidFill>
-            <a:ln>
-              <a:solidFill>
-                <a:srgbClr val="2B8A3A"/>
-              </a:solidFill>
-            </a:ln>
-          </p:spPr>
-          <p:style>
-            <a:lnRef idx="1">
-              <a:schemeClr val="accent1"/>
-            </a:lnRef>
-            <a:fillRef idx="3">
-              <a:schemeClr val="accent1"/>
-            </a:fillRef>
-            <a:effectRef idx="2">
-              <a:schemeClr val="accent1"/>
-            </a:effectRef>
-            <a:fontRef idx="minor">
-              <a:schemeClr val="lt1"/>
-            </a:fontRef>
-          </p:style>
-          <p:txBody>
-            <a:bodyPr rtlCol="0" anchor="ctr"/>
-            <a:lstStyle/>
-            <a:p>
-              <a:r>
-                <a:rPr sz="900" b="1">
-                  <a:solidFill>
-                    <a:srgbClr val="FFFFFF"/>
-                  </a:solidFill>
-                </a:rPr>
-                <a:t>要補圖</a:t>
-              </a:r>
-            </a:p>
-            <a:p>
-              <a:r>
-                <a:rPr sz="900" b="1">
-                  <a:solidFill>
-                    <a:srgbClr val="FFFFFF"/>
-                  </a:solidFill>
-                </a:rPr>
-                <a:t>tomb_ashpit</a:t>
-              </a:r>
-            </a:p>
-          </p:txBody>
-        </p:sp>
+          </p:spPr>
+        </p:pic>
         <p:sp>
           <p:nvSpPr>
             <p:cNvPr id="119" name="TextBox 118"/>
@@ -6679,12 +6261,20 @@
             <a:chExt cx="1280000" cy="1020000"/>
           </a:xfrm>
         </p:grpSpPr>
-        <p:sp>
-          <p:nvSpPr>
-            <p:cNvPr id="121" name="Rectangle 120"/>
-            <p:cNvSpPr/>
-            <p:nvPr/>
-          </p:nvSpPr>
+        <p:pic>
+          <p:nvPicPr>
+            <p:cNvPr id="121" name="Picture 120" descr="tomb_graveldrop.webp.jpg"/>
+            <p:cNvPicPr>
+              <a:picLocks noChangeAspect="1"/>
+            </p:cNvPicPr>
+            <p:nvPr/>
+          </p:nvPicPr>
+          <p:blipFill>
+            <a:blip r:embed="rId41"/>
+            <a:stretch>
+              <a:fillRect/>
+            </a:stretch>
+          </p:blipFill>
           <p:spPr>
             <a:xfrm>
               <a:off x="18300000" y="10200000"/>
@@ -6693,54 +6283,8 @@
             <a:prstGeom prst="rect">
               <a:avLst/>
             </a:prstGeom>
-            <a:solidFill>
-              <a:srgbClr val="3FB950"/>
-            </a:solidFill>
-            <a:ln>
-              <a:solidFill>
-                <a:srgbClr val="2B8A3A"/>
-              </a:solidFill>
-            </a:ln>
-          </p:spPr>
-          <p:style>
-            <a:lnRef idx="1">
-              <a:schemeClr val="accent1"/>
-            </a:lnRef>
-            <a:fillRef idx="3">
-              <a:schemeClr val="accent1"/>
-            </a:fillRef>
-            <a:effectRef idx="2">
-              <a:schemeClr val="accent1"/>
-            </a:effectRef>
-            <a:fontRef idx="minor">
-              <a:schemeClr val="lt1"/>
-            </a:fontRef>
-          </p:style>
-          <p:txBody>
-            <a:bodyPr rtlCol="0" anchor="ctr"/>
-            <a:lstStyle/>
-            <a:p>
-              <a:r>
-                <a:rPr sz="900" b="1">
-                  <a:solidFill>
-                    <a:srgbClr val="FFFFFF"/>
-                  </a:solidFill>
-                </a:rPr>
-                <a:t>要補圖</a:t>
-              </a:r>
-            </a:p>
-            <a:p>
-              <a:r>
-                <a:rPr sz="900" b="1">
-                  <a:solidFill>
-                    <a:srgbClr val="FFFFFF"/>
-                  </a:solidFill>
-                </a:rPr>
-                <a:t>tomb_graveldrop</a:t>
-              </a:r>
-            </a:p>
-          </p:txBody>
-        </p:sp>
+          </p:spPr>
+        </p:pic>
         <p:sp>
           <p:nvSpPr>
             <p:cNvPr id="122" name="TextBox 121"/>
@@ -6797,12 +6341,20 @@
             <a:chExt cx="1280000" cy="1020000"/>
           </a:xfrm>
         </p:grpSpPr>
-        <p:sp>
-          <p:nvSpPr>
-            <p:cNvPr id="124" name="Rectangle 123"/>
-            <p:cNvSpPr/>
-            <p:nvPr/>
-          </p:nvSpPr>
+        <p:pic>
+          <p:nvPicPr>
+            <p:cNvPr id="124" name="Picture 123" descr="tomb_saltroom.webp.jpg"/>
+            <p:cNvPicPr>
+              <a:picLocks noChangeAspect="1"/>
+            </p:cNvPicPr>
+            <p:nvPr/>
+          </p:nvPicPr>
+          <p:blipFill>
+            <a:blip r:embed="rId42"/>
+            <a:stretch>
+              <a:fillRect/>
+            </a:stretch>
+          </p:blipFill>
           <p:spPr>
             <a:xfrm>
               <a:off x="21300000" y="7900000"/>
@@ -6811,54 +6363,8 @@
             <a:prstGeom prst="rect">
               <a:avLst/>
             </a:prstGeom>
-            <a:solidFill>
-              <a:srgbClr val="3FB950"/>
-            </a:solidFill>
-            <a:ln>
-              <a:solidFill>
-                <a:srgbClr val="2B8A3A"/>
-              </a:solidFill>
-            </a:ln>
-          </p:spPr>
-          <p:style>
-            <a:lnRef idx="1">
-              <a:schemeClr val="accent1"/>
-            </a:lnRef>
-            <a:fillRef idx="3">
-              <a:schemeClr val="accent1"/>
-            </a:fillRef>
-            <a:effectRef idx="2">
-              <a:schemeClr val="accent1"/>
-            </a:effectRef>
-            <a:fontRef idx="minor">
-              <a:schemeClr val="lt1"/>
-            </a:fontRef>
-          </p:style>
-          <p:txBody>
-            <a:bodyPr rtlCol="0" anchor="ctr"/>
-            <a:lstStyle/>
-            <a:p>
-              <a:r>
-                <a:rPr sz="900" b="1">
-                  <a:solidFill>
-                    <a:srgbClr val="FFFFFF"/>
-                  </a:solidFill>
-                </a:rPr>
-                <a:t>要補圖</a:t>
-              </a:r>
-            </a:p>
-            <a:p>
-              <a:r>
-                <a:rPr sz="900" b="1">
-                  <a:solidFill>
-                    <a:srgbClr val="FFFFFF"/>
-                  </a:solidFill>
-                </a:rPr>
-                <a:t>tomb_saltroom</a:t>
-              </a:r>
-            </a:p>
-          </p:txBody>
-        </p:sp>
+          </p:spPr>
+        </p:pic>
         <p:sp>
           <p:nvSpPr>
             <p:cNvPr id="125" name="TextBox 124"/>
@@ -6915,12 +6421,20 @@
             <a:chExt cx="1280000" cy="1020000"/>
           </a:xfrm>
         </p:grpSpPr>
-        <p:sp>
-          <p:nvSpPr>
-            <p:cNvPr id="127" name="Rectangle 126"/>
-            <p:cNvSpPr/>
-            <p:nvPr/>
-          </p:nvSpPr>
+        <p:pic>
+          <p:nvPicPr>
+            <p:cNvPr id="127" name="Picture 126" descr="tomb_chimney.webp.jpg"/>
+            <p:cNvPicPr>
+              <a:picLocks noChangeAspect="1"/>
+            </p:cNvPicPr>
+            <p:nvPr/>
+          </p:nvPicPr>
+          <p:blipFill>
+            <a:blip r:embed="rId43"/>
+            <a:stretch>
+              <a:fillRect/>
+            </a:stretch>
+          </p:blipFill>
           <p:spPr>
             <a:xfrm>
               <a:off x="21300000" y="6750000"/>
@@ -6929,54 +6443,8 @@
             <a:prstGeom prst="rect">
               <a:avLst/>
             </a:prstGeom>
-            <a:solidFill>
-              <a:srgbClr val="3FB950"/>
-            </a:solidFill>
-            <a:ln>
-              <a:solidFill>
-                <a:srgbClr val="2B8A3A"/>
-              </a:solidFill>
-            </a:ln>
-          </p:spPr>
-          <p:style>
-            <a:lnRef idx="1">
-              <a:schemeClr val="accent1"/>
-            </a:lnRef>
-            <a:fillRef idx="3">
-              <a:schemeClr val="accent1"/>
-            </a:fillRef>
-            <a:effectRef idx="2">
-              <a:schemeClr val="accent1"/>
-            </a:effectRef>
-            <a:fontRef idx="minor">
-              <a:schemeClr val="lt1"/>
-            </a:fontRef>
-          </p:style>
-          <p:txBody>
-            <a:bodyPr rtlCol="0" anchor="ctr"/>
-            <a:lstStyle/>
-            <a:p>
-              <a:r>
-                <a:rPr sz="900" b="1">
-                  <a:solidFill>
-                    <a:srgbClr val="FFFFFF"/>
-                  </a:solidFill>
-                </a:rPr>
-                <a:t>要補圖</a:t>
-              </a:r>
-            </a:p>
-            <a:p>
-              <a:r>
-                <a:rPr sz="900" b="1">
-                  <a:solidFill>
-                    <a:srgbClr val="FFFFFF"/>
-                  </a:solidFill>
-                </a:rPr>
-                <a:t>tomb_chimney</a:t>
-              </a:r>
-            </a:p>
-          </p:txBody>
-        </p:sp>
+          </p:spPr>
+        </p:pic>
         <p:sp>
           <p:nvSpPr>
             <p:cNvPr id="128" name="TextBox 127"/>
@@ -7033,12 +6501,20 @@
             <a:chExt cx="1280000" cy="1020000"/>
           </a:xfrm>
         </p:grpSpPr>
-        <p:sp>
-          <p:nvSpPr>
-            <p:cNvPr id="130" name="Rectangle 129"/>
-            <p:cNvSpPr/>
-            <p:nvPr/>
-          </p:nvSpPr>
+        <p:pic>
+          <p:nvPicPr>
+            <p:cNvPr id="130" name="Picture 129" descr="tomb_nitrepit.webp.jpg"/>
+            <p:cNvPicPr>
+              <a:picLocks noChangeAspect="1"/>
+            </p:cNvPicPr>
+            <p:nvPr/>
+          </p:nvPicPr>
+          <p:blipFill>
+            <a:blip r:embed="rId44"/>
+            <a:stretch>
+              <a:fillRect/>
+            </a:stretch>
+          </p:blipFill>
           <p:spPr>
             <a:xfrm>
               <a:off x="24300000" y="7900000"/>
@@ -7047,54 +6523,8 @@
             <a:prstGeom prst="rect">
               <a:avLst/>
             </a:prstGeom>
-            <a:solidFill>
-              <a:srgbClr val="3FB950"/>
-            </a:solidFill>
-            <a:ln>
-              <a:solidFill>
-                <a:srgbClr val="2B8A3A"/>
-              </a:solidFill>
-            </a:ln>
-          </p:spPr>
-          <p:style>
-            <a:lnRef idx="1">
-              <a:schemeClr val="accent1"/>
-            </a:lnRef>
-            <a:fillRef idx="3">
-              <a:schemeClr val="accent1"/>
-            </a:fillRef>
-            <a:effectRef idx="2">
-              <a:schemeClr val="accent1"/>
-            </a:effectRef>
-            <a:fontRef idx="minor">
-              <a:schemeClr val="lt1"/>
-            </a:fontRef>
-          </p:style>
-          <p:txBody>
-            <a:bodyPr rtlCol="0" anchor="ctr"/>
-            <a:lstStyle/>
-            <a:p>
-              <a:r>
-                <a:rPr sz="900" b="1">
-                  <a:solidFill>
-                    <a:srgbClr val="FFFFFF"/>
-                  </a:solidFill>
-                </a:rPr>
-                <a:t>要補圖</a:t>
-              </a:r>
-            </a:p>
-            <a:p>
-              <a:r>
-                <a:rPr sz="900" b="1">
-                  <a:solidFill>
-                    <a:srgbClr val="FFFFFF"/>
-                  </a:solidFill>
-                </a:rPr>
-                <a:t>tomb_nitrepit</a:t>
-              </a:r>
-            </a:p>
-          </p:txBody>
-        </p:sp>
+          </p:spPr>
+        </p:pic>
         <p:sp>
           <p:nvSpPr>
             <p:cNvPr id="131" name="TextBox 130"/>
@@ -7151,12 +6581,20 @@
             <a:chExt cx="1280000" cy="1020000"/>
           </a:xfrm>
         </p:grpSpPr>
-        <p:sp>
-          <p:nvSpPr>
-            <p:cNvPr id="133" name="Rectangle 132"/>
-            <p:cNvSpPr/>
-            <p:nvPr/>
-          </p:nvSpPr>
+        <p:pic>
+          <p:nvPicPr>
+            <p:cNvPr id="133" name="Picture 132" descr="tomb_masonhall.webp.jpg"/>
+            <p:cNvPicPr>
+              <a:picLocks noChangeAspect="1"/>
+            </p:cNvPicPr>
+            <p:nvPr/>
+          </p:nvPicPr>
+          <p:blipFill>
+            <a:blip r:embed="rId45"/>
+            <a:stretch>
+              <a:fillRect/>
+            </a:stretch>
+          </p:blipFill>
           <p:spPr>
             <a:xfrm>
               <a:off x="24300000" y="9050000"/>
@@ -7165,54 +6603,8 @@
             <a:prstGeom prst="rect">
               <a:avLst/>
             </a:prstGeom>
-            <a:solidFill>
-              <a:srgbClr val="3FB950"/>
-            </a:solidFill>
-            <a:ln>
-              <a:solidFill>
-                <a:srgbClr val="2B8A3A"/>
-              </a:solidFill>
-            </a:ln>
-          </p:spPr>
-          <p:style>
-            <a:lnRef idx="1">
-              <a:schemeClr val="accent1"/>
-            </a:lnRef>
-            <a:fillRef idx="3">
-              <a:schemeClr val="accent1"/>
-            </a:fillRef>
-            <a:effectRef idx="2">
-              <a:schemeClr val="accent1"/>
-            </a:effectRef>
-            <a:fontRef idx="minor">
-              <a:schemeClr val="lt1"/>
-            </a:fontRef>
-          </p:style>
-          <p:txBody>
-            <a:bodyPr rtlCol="0" anchor="ctr"/>
-            <a:lstStyle/>
-            <a:p>
-              <a:r>
-                <a:rPr sz="900" b="1">
-                  <a:solidFill>
-                    <a:srgbClr val="FFFFFF"/>
-                  </a:solidFill>
-                </a:rPr>
-                <a:t>要補圖</a:t>
-              </a:r>
-            </a:p>
-            <a:p>
-              <a:r>
-                <a:rPr sz="900" b="1">
-                  <a:solidFill>
-                    <a:srgbClr val="FFFFFF"/>
-                  </a:solidFill>
-                </a:rPr>
-                <a:t>tomb_masonhall</a:t>
-              </a:r>
-            </a:p>
-          </p:txBody>
-        </p:sp>
+          </p:spPr>
+        </p:pic>
         <p:sp>
           <p:nvSpPr>
             <p:cNvPr id="134" name="TextBox 133"/>
@@ -7269,12 +6661,20 @@
             <a:chExt cx="1280000" cy="1020000"/>
           </a:xfrm>
         </p:grpSpPr>
-        <p:sp>
-          <p:nvSpPr>
-            <p:cNvPr id="136" name="Rectangle 135"/>
-            <p:cNvSpPr/>
-            <p:nvPr/>
-          </p:nvSpPr>
+        <p:pic>
+          <p:nvPicPr>
+            <p:cNvPr id="136" name="Picture 135" descr="tomb_toolniche.webp.jpg"/>
+            <p:cNvPicPr>
+              <a:picLocks noChangeAspect="1"/>
+            </p:cNvPicPr>
+            <p:nvPr/>
+          </p:nvPicPr>
+          <p:blipFill>
+            <a:blip r:embed="rId46"/>
+            <a:stretch>
+              <a:fillRect/>
+            </a:stretch>
+          </p:blipFill>
           <p:spPr>
             <a:xfrm>
               <a:off x="27300000" y="9050000"/>
@@ -7283,54 +6683,8 @@
             <a:prstGeom prst="rect">
               <a:avLst/>
             </a:prstGeom>
-            <a:solidFill>
-              <a:srgbClr val="3FB950"/>
-            </a:solidFill>
-            <a:ln>
-              <a:solidFill>
-                <a:srgbClr val="2B8A3A"/>
-              </a:solidFill>
-            </a:ln>
-          </p:spPr>
-          <p:style>
-            <a:lnRef idx="1">
-              <a:schemeClr val="accent1"/>
-            </a:lnRef>
-            <a:fillRef idx="3">
-              <a:schemeClr val="accent1"/>
-            </a:fillRef>
-            <a:effectRef idx="2">
-              <a:schemeClr val="accent1"/>
-            </a:effectRef>
-            <a:fontRef idx="minor">
-              <a:schemeClr val="lt1"/>
-            </a:fontRef>
-          </p:style>
-          <p:txBody>
-            <a:bodyPr rtlCol="0" anchor="ctr"/>
-            <a:lstStyle/>
-            <a:p>
-              <a:r>
-                <a:rPr sz="900" b="1">
-                  <a:solidFill>
-                    <a:srgbClr val="FFFFFF"/>
-                  </a:solidFill>
-                </a:rPr>
-                <a:t>要補圖</a:t>
-              </a:r>
-            </a:p>
-            <a:p>
-              <a:r>
-                <a:rPr sz="900" b="1">
-                  <a:solidFill>
-                    <a:srgbClr val="FFFFFF"/>
-                  </a:solidFill>
-                </a:rPr>
-                <a:t>tomb_toolniche</a:t>
-              </a:r>
-            </a:p>
-          </p:txBody>
-        </p:sp>
+          </p:spPr>
+        </p:pic>
         <p:sp>
           <p:nvSpPr>
             <p:cNvPr id="137" name="TextBox 136"/>
@@ -7387,12 +6741,20 @@
             <a:chExt cx="1280000" cy="1020000"/>
           </a:xfrm>
         </p:grpSpPr>
-        <p:sp>
-          <p:nvSpPr>
-            <p:cNvPr id="139" name="Rectangle 138"/>
-            <p:cNvSpPr/>
-            <p:nvPr/>
-          </p:nvSpPr>
+        <p:pic>
+          <p:nvPicPr>
+            <p:cNvPr id="139" name="Picture 138" descr="tomb_rubble.webp.jpg"/>
+            <p:cNvPicPr>
+              <a:picLocks noChangeAspect="1"/>
+            </p:cNvPicPr>
+            <p:nvPr/>
+          </p:nvPicPr>
+          <p:blipFill>
+            <a:blip r:embed="rId47"/>
+            <a:stretch>
+              <a:fillRect/>
+            </a:stretch>
+          </p:blipFill>
           <p:spPr>
             <a:xfrm>
               <a:off x="24300000" y="10200000"/>
@@ -7401,54 +6763,8 @@
             <a:prstGeom prst="rect">
               <a:avLst/>
             </a:prstGeom>
-            <a:solidFill>
-              <a:srgbClr val="3FB950"/>
-            </a:solidFill>
-            <a:ln>
-              <a:solidFill>
-                <a:srgbClr val="2B8A3A"/>
-              </a:solidFill>
-            </a:ln>
-          </p:spPr>
-          <p:style>
-            <a:lnRef idx="1">
-              <a:schemeClr val="accent1"/>
-            </a:lnRef>
-            <a:fillRef idx="3">
-              <a:schemeClr val="accent1"/>
-            </a:fillRef>
-            <a:effectRef idx="2">
-              <a:schemeClr val="accent1"/>
-            </a:effectRef>
-            <a:fontRef idx="minor">
-              <a:schemeClr val="lt1"/>
-            </a:fontRef>
-          </p:style>
-          <p:txBody>
-            <a:bodyPr rtlCol="0" anchor="ctr"/>
-            <a:lstStyle/>
-            <a:p>
-              <a:r>
-                <a:rPr sz="900" b="1">
-                  <a:solidFill>
-                    <a:srgbClr val="FFFFFF"/>
-                  </a:solidFill>
-                </a:rPr>
-                <a:t>要補圖</a:t>
-              </a:r>
-            </a:p>
-            <a:p>
-              <a:r>
-                <a:rPr sz="900" b="1">
-                  <a:solidFill>
-                    <a:srgbClr val="FFFFFF"/>
-                  </a:solidFill>
-                </a:rPr>
-                <a:t>tomb_rubble</a:t>
-              </a:r>
-            </a:p>
-          </p:txBody>
-        </p:sp>
+          </p:spPr>
+        </p:pic>
         <p:sp>
           <p:nvSpPr>
             <p:cNvPr id="140" name="TextBox 139"/>
@@ -7505,12 +6821,20 @@
             <a:chExt cx="1280000" cy="1020000"/>
           </a:xfrm>
         </p:grpSpPr>
-        <p:sp>
-          <p:nvSpPr>
-            <p:cNvPr id="142" name="Rectangle 141"/>
-            <p:cNvSpPr/>
-            <p:nvPr/>
-          </p:nvSpPr>
+        <p:pic>
+          <p:nvPicPr>
+            <p:cNvPr id="142" name="Picture 141" descr="tomb_cryptwalk.webp.jpg"/>
+            <p:cNvPicPr>
+              <a:picLocks noChangeAspect="1"/>
+            </p:cNvPicPr>
+            <p:nvPr/>
+          </p:nvPicPr>
+          <p:blipFill>
+            <a:blip r:embed="rId48"/>
+            <a:stretch>
+              <a:fillRect/>
+            </a:stretch>
+          </p:blipFill>
           <p:spPr>
             <a:xfrm>
               <a:off x="21300000" y="11350000"/>
@@ -7519,54 +6843,8 @@
             <a:prstGeom prst="rect">
               <a:avLst/>
             </a:prstGeom>
-            <a:solidFill>
-              <a:srgbClr val="3FB950"/>
-            </a:solidFill>
-            <a:ln>
-              <a:solidFill>
-                <a:srgbClr val="2B8A3A"/>
-              </a:solidFill>
-            </a:ln>
-          </p:spPr>
-          <p:style>
-            <a:lnRef idx="1">
-              <a:schemeClr val="accent1"/>
-            </a:lnRef>
-            <a:fillRef idx="3">
-              <a:schemeClr val="accent1"/>
-            </a:fillRef>
-            <a:effectRef idx="2">
-              <a:schemeClr val="accent1"/>
-            </a:effectRef>
-            <a:fontRef idx="minor">
-              <a:schemeClr val="lt1"/>
-            </a:fontRef>
-          </p:style>
-          <p:txBody>
-            <a:bodyPr rtlCol="0" anchor="ctr"/>
-            <a:lstStyle/>
-            <a:p>
-              <a:r>
-                <a:rPr sz="900" b="1">
-                  <a:solidFill>
-                    <a:srgbClr val="FFFFFF"/>
-                  </a:solidFill>
-                </a:rPr>
-                <a:t>要補圖</a:t>
-              </a:r>
-            </a:p>
-            <a:p>
-              <a:r>
-                <a:rPr sz="900" b="1">
-                  <a:solidFill>
-                    <a:srgbClr val="FFFFFF"/>
-                  </a:solidFill>
-                </a:rPr>
-                <a:t>tomb_cryptwalk</a:t>
-              </a:r>
-            </a:p>
-          </p:txBody>
-        </p:sp>
+          </p:spPr>
+        </p:pic>
         <p:sp>
           <p:nvSpPr>
             <p:cNvPr id="143" name="TextBox 142"/>
@@ -7623,12 +6901,20 @@
             <a:chExt cx="1280000" cy="1020000"/>
           </a:xfrm>
         </p:grpSpPr>
-        <p:sp>
-          <p:nvSpPr>
-            <p:cNvPr id="145" name="Rectangle 144"/>
-            <p:cNvSpPr/>
-            <p:nvPr/>
-          </p:nvSpPr>
+        <p:pic>
+          <p:nvPicPr>
+            <p:cNvPr id="145" name="Picture 144" descr="tomb_deepwalk.webp.jpg"/>
+            <p:cNvPicPr>
+              <a:picLocks noChangeAspect="1"/>
+            </p:cNvPicPr>
+            <p:nvPr/>
+          </p:nvPicPr>
+          <p:blipFill>
+            <a:blip r:embed="rId49"/>
+            <a:stretch>
+              <a:fillRect/>
+            </a:stretch>
+          </p:blipFill>
           <p:spPr>
             <a:xfrm>
               <a:off x="21300000" y="12500000"/>
@@ -7637,54 +6923,8 @@
             <a:prstGeom prst="rect">
               <a:avLst/>
             </a:prstGeom>
-            <a:solidFill>
-              <a:srgbClr val="3FB950"/>
-            </a:solidFill>
-            <a:ln>
-              <a:solidFill>
-                <a:srgbClr val="2B8A3A"/>
-              </a:solidFill>
-            </a:ln>
-          </p:spPr>
-          <p:style>
-            <a:lnRef idx="1">
-              <a:schemeClr val="accent1"/>
-            </a:lnRef>
-            <a:fillRef idx="3">
-              <a:schemeClr val="accent1"/>
-            </a:fillRef>
-            <a:effectRef idx="2">
-              <a:schemeClr val="accent1"/>
-            </a:effectRef>
-            <a:fontRef idx="minor">
-              <a:schemeClr val="lt1"/>
-            </a:fontRef>
-          </p:style>
-          <p:txBody>
-            <a:bodyPr rtlCol="0" anchor="ctr"/>
-            <a:lstStyle/>
-            <a:p>
-              <a:r>
-                <a:rPr sz="900" b="1">
-                  <a:solidFill>
-                    <a:srgbClr val="FFFFFF"/>
-                  </a:solidFill>
-                </a:rPr>
-                <a:t>要補圖</a:t>
-              </a:r>
-            </a:p>
-            <a:p>
-              <a:r>
-                <a:rPr sz="900" b="1">
-                  <a:solidFill>
-                    <a:srgbClr val="FFFFFF"/>
-                  </a:solidFill>
-                </a:rPr>
-                <a:t>tomb_deepwalk</a:t>
-              </a:r>
-            </a:p>
-          </p:txBody>
-        </p:sp>
+          </p:spPr>
+        </p:pic>
         <p:sp>
           <p:nvSpPr>
             <p:cNvPr id="146" name="TextBox 145"/>
@@ -7741,12 +6981,20 @@
             <a:chExt cx="1280000" cy="1020000"/>
           </a:xfrm>
         </p:grpSpPr>
-        <p:sp>
-          <p:nvSpPr>
-            <p:cNvPr id="148" name="Rectangle 147"/>
-            <p:cNvSpPr/>
-            <p:nvPr/>
-          </p:nvSpPr>
+        <p:pic>
+          <p:nvPicPr>
+            <p:cNvPr id="148" name="Picture 147" descr="tomb_brokenhall.webp.jpg"/>
+            <p:cNvPicPr>
+              <a:picLocks noChangeAspect="1"/>
+            </p:cNvPicPr>
+            <p:nvPr/>
+          </p:nvPicPr>
+          <p:blipFill>
+            <a:blip r:embed="rId50"/>
+            <a:stretch>
+              <a:fillRect/>
+            </a:stretch>
+          </p:blipFill>
           <p:spPr>
             <a:xfrm>
               <a:off x="18300000" y="12500000"/>
@@ -7755,54 +7003,8 @@
             <a:prstGeom prst="rect">
               <a:avLst/>
             </a:prstGeom>
-            <a:solidFill>
-              <a:srgbClr val="3FB950"/>
-            </a:solidFill>
-            <a:ln>
-              <a:solidFill>
-                <a:srgbClr val="2B8A3A"/>
-              </a:solidFill>
-            </a:ln>
-          </p:spPr>
-          <p:style>
-            <a:lnRef idx="1">
-              <a:schemeClr val="accent1"/>
-            </a:lnRef>
-            <a:fillRef idx="3">
-              <a:schemeClr val="accent1"/>
-            </a:fillRef>
-            <a:effectRef idx="2">
-              <a:schemeClr val="accent1"/>
-            </a:effectRef>
-            <a:fontRef idx="minor">
-              <a:schemeClr val="lt1"/>
-            </a:fontRef>
-          </p:style>
-          <p:txBody>
-            <a:bodyPr rtlCol="0" anchor="ctr"/>
-            <a:lstStyle/>
-            <a:p>
-              <a:r>
-                <a:rPr sz="900" b="1">
-                  <a:solidFill>
-                    <a:srgbClr val="FFFFFF"/>
-                  </a:solidFill>
-                </a:rPr>
-                <a:t>要補圖</a:t>
-              </a:r>
-            </a:p>
-            <a:p>
-              <a:r>
-                <a:rPr sz="900" b="1">
-                  <a:solidFill>
-                    <a:srgbClr val="FFFFFF"/>
-                  </a:solidFill>
-                </a:rPr>
-                <a:t>tomb_brokenhall</a:t>
-              </a:r>
-            </a:p>
-          </p:txBody>
-        </p:sp>
+          </p:spPr>
+        </p:pic>
         <p:sp>
           <p:nvSpPr>
             <p:cNvPr id="149" name="TextBox 148"/>
@@ -7859,12 +7061,20 @@
             <a:chExt cx="1280000" cy="1020000"/>
           </a:xfrm>
         </p:grpSpPr>
-        <p:sp>
-          <p:nvSpPr>
-            <p:cNvPr id="151" name="Rectangle 150"/>
-            <p:cNvSpPr/>
-            <p:nvPr/>
-          </p:nvSpPr>
+        <p:pic>
+          <p:nvPicPr>
+            <p:cNvPr id="151" name="Picture 150" descr="tomb_sunkhall.webp.jpg"/>
+            <p:cNvPicPr>
+              <a:picLocks noChangeAspect="1"/>
+            </p:cNvPicPr>
+            <p:nvPr/>
+          </p:nvPicPr>
+          <p:blipFill>
+            <a:blip r:embed="rId51"/>
+            <a:stretch>
+              <a:fillRect/>
+            </a:stretch>
+          </p:blipFill>
           <p:spPr>
             <a:xfrm>
               <a:off x="21300000" y="14800000"/>
@@ -7873,54 +7083,8 @@
             <a:prstGeom prst="rect">
               <a:avLst/>
             </a:prstGeom>
-            <a:solidFill>
-              <a:srgbClr val="3FB950"/>
-            </a:solidFill>
-            <a:ln>
-              <a:solidFill>
-                <a:srgbClr val="2B8A3A"/>
-              </a:solidFill>
-            </a:ln>
-          </p:spPr>
-          <p:style>
-            <a:lnRef idx="1">
-              <a:schemeClr val="accent1"/>
-            </a:lnRef>
-            <a:fillRef idx="3">
-              <a:schemeClr val="accent1"/>
-            </a:fillRef>
-            <a:effectRef idx="2">
-              <a:schemeClr val="accent1"/>
-            </a:effectRef>
-            <a:fontRef idx="minor">
-              <a:schemeClr val="lt1"/>
-            </a:fontRef>
-          </p:style>
-          <p:txBody>
-            <a:bodyPr rtlCol="0" anchor="ctr"/>
-            <a:lstStyle/>
-            <a:p>
-              <a:r>
-                <a:rPr sz="900" b="1">
-                  <a:solidFill>
-                    <a:srgbClr val="FFFFFF"/>
-                  </a:solidFill>
-                </a:rPr>
-                <a:t>要補圖</a:t>
-              </a:r>
-            </a:p>
-            <a:p>
-              <a:r>
-                <a:rPr sz="900" b="1">
-                  <a:solidFill>
-                    <a:srgbClr val="FFFFFF"/>
-                  </a:solidFill>
-                </a:rPr>
-                <a:t>tomb_sunkhall</a:t>
-              </a:r>
-            </a:p>
-          </p:txBody>
-        </p:sp>
+          </p:spPr>
+        </p:pic>
         <p:sp>
           <p:nvSpPr>
             <p:cNvPr id="152" name="TextBox 151"/>
@@ -7977,12 +7141,20 @@
             <a:chExt cx="1280000" cy="1020000"/>
           </a:xfrm>
         </p:grpSpPr>
-        <p:sp>
-          <p:nvSpPr>
-            <p:cNvPr id="154" name="Rectangle 153"/>
-            <p:cNvSpPr/>
-            <p:nvPr/>
-          </p:nvSpPr>
+        <p:pic>
+          <p:nvPicPr>
+            <p:cNvPr id="154" name="Picture 153" descr="tomb_mudpit.webp.jpg"/>
+            <p:cNvPicPr>
+              <a:picLocks noChangeAspect="1"/>
+            </p:cNvPicPr>
+            <p:nvPr/>
+          </p:nvPicPr>
+          <p:blipFill>
+            <a:blip r:embed="rId52"/>
+            <a:stretch>
+              <a:fillRect/>
+            </a:stretch>
+          </p:blipFill>
           <p:spPr>
             <a:xfrm>
               <a:off x="21300000" y="15950000"/>
@@ -7991,54 +7163,8 @@
             <a:prstGeom prst="rect">
               <a:avLst/>
             </a:prstGeom>
-            <a:solidFill>
-              <a:srgbClr val="3FB950"/>
-            </a:solidFill>
-            <a:ln>
-              <a:solidFill>
-                <a:srgbClr val="2B8A3A"/>
-              </a:solidFill>
-            </a:ln>
-          </p:spPr>
-          <p:style>
-            <a:lnRef idx="1">
-              <a:schemeClr val="accent1"/>
-            </a:lnRef>
-            <a:fillRef idx="3">
-              <a:schemeClr val="accent1"/>
-            </a:fillRef>
-            <a:effectRef idx="2">
-              <a:schemeClr val="accent1"/>
-            </a:effectRef>
-            <a:fontRef idx="minor">
-              <a:schemeClr val="lt1"/>
-            </a:fontRef>
-          </p:style>
-          <p:txBody>
-            <a:bodyPr rtlCol="0" anchor="ctr"/>
-            <a:lstStyle/>
-            <a:p>
-              <a:r>
-                <a:rPr sz="900" b="1">
-                  <a:solidFill>
-                    <a:srgbClr val="FFFFFF"/>
-                  </a:solidFill>
-                </a:rPr>
-                <a:t>要補圖</a:t>
-              </a:r>
-            </a:p>
-            <a:p>
-              <a:r>
-                <a:rPr sz="900" b="1">
-                  <a:solidFill>
-                    <a:srgbClr val="FFFFFF"/>
-                  </a:solidFill>
-                </a:rPr>
-                <a:t>tomb_mudpit</a:t>
-              </a:r>
-            </a:p>
-          </p:txBody>
-        </p:sp>
+          </p:spPr>
+        </p:pic>
         <p:sp>
           <p:nvSpPr>
             <p:cNvPr id="155" name="TextBox 154"/>
@@ -8095,12 +7221,20 @@
             <a:chExt cx="1280000" cy="1020000"/>
           </a:xfrm>
         </p:grpSpPr>
-        <p:sp>
-          <p:nvSpPr>
-            <p:cNvPr id="157" name="Rectangle 156"/>
-            <p:cNvSpPr/>
-            <p:nvPr/>
-          </p:nvSpPr>
+        <p:pic>
+          <p:nvPicPr>
+            <p:cNvPr id="157" name="Picture 156" descr="tomb_crossvault.webp.jpg"/>
+            <p:cNvPicPr>
+              <a:picLocks noChangeAspect="1"/>
+            </p:cNvPicPr>
+            <p:nvPr/>
+          </p:nvPicPr>
+          <p:blipFill>
+            <a:blip r:embed="rId53"/>
+            <a:stretch>
+              <a:fillRect/>
+            </a:stretch>
+          </p:blipFill>
           <p:spPr>
             <a:xfrm>
               <a:off x="21300000" y="13650000"/>
@@ -8109,54 +7243,8 @@
             <a:prstGeom prst="rect">
               <a:avLst/>
             </a:prstGeom>
-            <a:solidFill>
-              <a:srgbClr val="3FB950"/>
-            </a:solidFill>
-            <a:ln>
-              <a:solidFill>
-                <a:srgbClr val="2B8A3A"/>
-              </a:solidFill>
-            </a:ln>
-          </p:spPr>
-          <p:style>
-            <a:lnRef idx="1">
-              <a:schemeClr val="accent1"/>
-            </a:lnRef>
-            <a:fillRef idx="3">
-              <a:schemeClr val="accent1"/>
-            </a:fillRef>
-            <a:effectRef idx="2">
-              <a:schemeClr val="accent1"/>
-            </a:effectRef>
-            <a:fontRef idx="minor">
-              <a:schemeClr val="lt1"/>
-            </a:fontRef>
-          </p:style>
-          <p:txBody>
-            <a:bodyPr rtlCol="0" anchor="ctr"/>
-            <a:lstStyle/>
-            <a:p>
-              <a:r>
-                <a:rPr sz="900" b="1">
-                  <a:solidFill>
-                    <a:srgbClr val="FFFFFF"/>
-                  </a:solidFill>
-                </a:rPr>
-                <a:t>要補圖</a:t>
-              </a:r>
-            </a:p>
-            <a:p>
-              <a:r>
-                <a:rPr sz="900" b="1">
-                  <a:solidFill>
-                    <a:srgbClr val="FFFFFF"/>
-                  </a:solidFill>
-                </a:rPr>
-                <a:t>tomb_crossvault</a:t>
-              </a:r>
-            </a:p>
-          </p:txBody>
-        </p:sp>
+          </p:spPr>
+        </p:pic>
         <p:sp>
           <p:nvSpPr>
             <p:cNvPr id="158" name="TextBox 157"/>
@@ -8213,12 +7301,20 @@
             <a:chExt cx="1280000" cy="1020000"/>
           </a:xfrm>
         </p:grpSpPr>
-        <p:sp>
-          <p:nvSpPr>
-            <p:cNvPr id="160" name="Rectangle 159"/>
-            <p:cNvSpPr/>
-            <p:nvPr/>
-          </p:nvSpPr>
+        <p:pic>
+          <p:nvPicPr>
+            <p:cNvPr id="160" name="Picture 159" descr="tomb_falsestair.webp.jpg"/>
+            <p:cNvPicPr>
+              <a:picLocks noChangeAspect="1"/>
+            </p:cNvPicPr>
+            <p:nvPr/>
+          </p:nvPicPr>
+          <p:blipFill>
+            <a:blip r:embed="rId54"/>
+            <a:stretch>
+              <a:fillRect/>
+            </a:stretch>
+          </p:blipFill>
           <p:spPr>
             <a:xfrm>
               <a:off x="18300000" y="13650000"/>
@@ -8227,54 +7323,8 @@
             <a:prstGeom prst="rect">
               <a:avLst/>
             </a:prstGeom>
-            <a:solidFill>
-              <a:srgbClr val="3FB950"/>
-            </a:solidFill>
-            <a:ln>
-              <a:solidFill>
-                <a:srgbClr val="2B8A3A"/>
-              </a:solidFill>
-            </a:ln>
-          </p:spPr>
-          <p:style>
-            <a:lnRef idx="1">
-              <a:schemeClr val="accent1"/>
-            </a:lnRef>
-            <a:fillRef idx="3">
-              <a:schemeClr val="accent1"/>
-            </a:fillRef>
-            <a:effectRef idx="2">
-              <a:schemeClr val="accent1"/>
-            </a:effectRef>
-            <a:fontRef idx="minor">
-              <a:schemeClr val="lt1"/>
-            </a:fontRef>
-          </p:style>
-          <p:txBody>
-            <a:bodyPr rtlCol="0" anchor="ctr"/>
-            <a:lstStyle/>
-            <a:p>
-              <a:r>
-                <a:rPr sz="900" b="1">
-                  <a:solidFill>
-                    <a:srgbClr val="FFFFFF"/>
-                  </a:solidFill>
-                </a:rPr>
-                <a:t>要補圖</a:t>
-              </a:r>
-            </a:p>
-            <a:p>
-              <a:r>
-                <a:rPr sz="900" b="1">
-                  <a:solidFill>
-                    <a:srgbClr val="FFFFFF"/>
-                  </a:solidFill>
-                </a:rPr>
-                <a:t>tomb_falsestair</a:t>
-              </a:r>
-            </a:p>
-          </p:txBody>
-        </p:sp>
+          </p:spPr>
+        </p:pic>
         <p:sp>
           <p:nvSpPr>
             <p:cNvPr id="161" name="TextBox 160"/>
@@ -8340,7 +7390,7 @@
             <p:nvPr/>
           </p:nvPicPr>
           <p:blipFill>
-            <a:blip r:embed="rId30"/>
+            <a:blip r:embed="rId55"/>
             <a:stretch>
               <a:fillRect/>
             </a:stretch>
@@ -8420,7 +7470,7 @@
             <p:nvPr/>
           </p:nvPicPr>
           <p:blipFill>
-            <a:blip r:embed="rId31"/>
+            <a:blip r:embed="rId56"/>
             <a:stretch>
               <a:fillRect/>
             </a:stretch>
@@ -8500,7 +7550,7 @@
             <p:nvPr/>
           </p:nvPicPr>
           <p:blipFill>
-            <a:blip r:embed="rId32"/>
+            <a:blip r:embed="rId57"/>
             <a:stretch>
               <a:fillRect/>
             </a:stretch>
@@ -8580,7 +7630,7 @@
             <p:nvPr/>
           </p:nvPicPr>
           <p:blipFill>
-            <a:blip r:embed="rId33"/>
+            <a:blip r:embed="rId58"/>
             <a:stretch>
               <a:fillRect/>
             </a:stretch>
@@ -8660,7 +7710,7 @@
             <p:nvPr/>
           </p:nvPicPr>
           <p:blipFill>
-            <a:blip r:embed="rId34"/>
+            <a:blip r:embed="rId59"/>
             <a:stretch>
               <a:fillRect/>
             </a:stretch>
@@ -8731,12 +7781,20 @@
             <a:chExt cx="1280000" cy="1020000"/>
           </a:xfrm>
         </p:grpSpPr>
-        <p:sp>
-          <p:nvSpPr>
-            <p:cNvPr id="178" name="Rectangle 177"/>
-            <p:cNvSpPr/>
-            <p:nvPr/>
-          </p:nvSpPr>
+        <p:pic>
+          <p:nvPicPr>
+            <p:cNvPr id="178" name="Picture 177" descr="tomb_lowaltar.webp.jpg"/>
+            <p:cNvPicPr>
+              <a:picLocks noChangeAspect="1"/>
+            </p:cNvPicPr>
+            <p:nvPr/>
+          </p:nvPicPr>
+          <p:blipFill>
+            <a:blip r:embed="rId60"/>
+            <a:stretch>
+              <a:fillRect/>
+            </a:stretch>
+          </p:blipFill>
           <p:spPr>
             <a:xfrm>
               <a:off x="27300000" y="18250000"/>
@@ -8745,54 +7803,8 @@
             <a:prstGeom prst="rect">
               <a:avLst/>
             </a:prstGeom>
-            <a:solidFill>
-              <a:srgbClr val="3FB950"/>
-            </a:solidFill>
-            <a:ln>
-              <a:solidFill>
-                <a:srgbClr val="2B8A3A"/>
-              </a:solidFill>
-            </a:ln>
-          </p:spPr>
-          <p:style>
-            <a:lnRef idx="1">
-              <a:schemeClr val="accent1"/>
-            </a:lnRef>
-            <a:fillRef idx="3">
-              <a:schemeClr val="accent1"/>
-            </a:fillRef>
-            <a:effectRef idx="2">
-              <a:schemeClr val="accent1"/>
-            </a:effectRef>
-            <a:fontRef idx="minor">
-              <a:schemeClr val="lt1"/>
-            </a:fontRef>
-          </p:style>
-          <p:txBody>
-            <a:bodyPr rtlCol="0" anchor="ctr"/>
-            <a:lstStyle/>
-            <a:p>
-              <a:r>
-                <a:rPr sz="900" b="1">
-                  <a:solidFill>
-                    <a:srgbClr val="FFFFFF"/>
-                  </a:solidFill>
-                </a:rPr>
-                <a:t>要補圖</a:t>
-              </a:r>
-            </a:p>
-            <a:p>
-              <a:r>
-                <a:rPr sz="900" b="1">
-                  <a:solidFill>
-                    <a:srgbClr val="FFFFFF"/>
-                  </a:solidFill>
-                </a:rPr>
-                <a:t>tomb_lowaltar</a:t>
-              </a:r>
-            </a:p>
-          </p:txBody>
-        </p:sp>
+          </p:spPr>
+        </p:pic>
         <p:sp>
           <p:nvSpPr>
             <p:cNvPr id="179" name="TextBox 178"/>
@@ -8849,12 +7861,20 @@
             <a:chExt cx="1280000" cy="1020000"/>
           </a:xfrm>
         </p:grpSpPr>
-        <p:sp>
-          <p:nvSpPr>
-            <p:cNvPr id="181" name="Rectangle 180"/>
-            <p:cNvSpPr/>
-            <p:nvPr/>
-          </p:nvSpPr>
+        <p:pic>
+          <p:nvPicPr>
+            <p:cNvPr id="181" name="Picture 180" descr="tomb_adit.webp.jpg"/>
+            <p:cNvPicPr>
+              <a:picLocks noChangeAspect="1"/>
+            </p:cNvPicPr>
+            <p:nvPr/>
+          </p:nvPicPr>
+          <p:blipFill>
+            <a:blip r:embed="rId61"/>
+            <a:stretch>
+              <a:fillRect/>
+            </a:stretch>
+          </p:blipFill>
           <p:spPr>
             <a:xfrm>
               <a:off x="24300000" y="18250000"/>
@@ -8863,54 +7883,8 @@
             <a:prstGeom prst="rect">
               <a:avLst/>
             </a:prstGeom>
-            <a:solidFill>
-              <a:srgbClr val="3FB950"/>
-            </a:solidFill>
-            <a:ln>
-              <a:solidFill>
-                <a:srgbClr val="2B8A3A"/>
-              </a:solidFill>
-            </a:ln>
-          </p:spPr>
-          <p:style>
-            <a:lnRef idx="1">
-              <a:schemeClr val="accent1"/>
-            </a:lnRef>
-            <a:fillRef idx="3">
-              <a:schemeClr val="accent1"/>
-            </a:fillRef>
-            <a:effectRef idx="2">
-              <a:schemeClr val="accent1"/>
-            </a:effectRef>
-            <a:fontRef idx="minor">
-              <a:schemeClr val="lt1"/>
-            </a:fontRef>
-          </p:style>
-          <p:txBody>
-            <a:bodyPr rtlCol="0" anchor="ctr"/>
-            <a:lstStyle/>
-            <a:p>
-              <a:r>
-                <a:rPr sz="900" b="1">
-                  <a:solidFill>
-                    <a:srgbClr val="FFFFFF"/>
-                  </a:solidFill>
-                </a:rPr>
-                <a:t>要補圖</a:t>
-              </a:r>
-            </a:p>
-            <a:p>
-              <a:r>
-                <a:rPr sz="900" b="1">
-                  <a:solidFill>
-                    <a:srgbClr val="FFFFFF"/>
-                  </a:solidFill>
-                </a:rPr>
-                <a:t>tomb_adit</a:t>
-              </a:r>
-            </a:p>
-          </p:txBody>
-        </p:sp>
+          </p:spPr>
+        </p:pic>
         <p:sp>
           <p:nvSpPr>
             <p:cNvPr id="182" name="TextBox 181"/>
@@ -8976,7 +7950,7 @@
             <p:nvPr/>
           </p:nvPicPr>
           <p:blipFill>
-            <a:blip r:embed="rId35"/>
+            <a:blip r:embed="rId62"/>
             <a:stretch>
               <a:fillRect/>
             </a:stretch>

</xml_diff>